<commit_message>
improved seq-diag and payee processing prose
</commit_message>
<xml_diff>
--- a/docgen/sequence-diagram.pptx
+++ b/docgen/sequence-diagram.pptx
@@ -197,7 +197,7 @@
           <a:p>
             <a:fld id="{9D12DC2B-A868-EB48-BC74-89BE29D1DE6E}" type="datetimeFigureOut">
               <a:rPr lang="en-US" smtClean="0"/>
-              <a:t>12/22/24</a:t>
+              <a:t>10/9/26</a:t>
             </a:fld>
             <a:endParaRPr lang="en-US" dirty="0"/>
           </a:p>
@@ -1348,119 +1348,12 @@
         </p:nvSpPr>
         <p:spPr>
           <a:xfrm>
-            <a:off x="4649888" y="2867025"/>
-            <a:ext cx="726313" cy="119040"/>
+            <a:off x="4754664" y="2867025"/>
+            <a:ext cx="626400" cy="119040"/>
           </a:xfrm>
-          <a:custGeom>
+          <a:prstGeom prst="leftRightArrow">
             <a:avLst/>
-            <a:gdLst>
-              <a:gd name="connsiteX0" fmla="*/ 0 w 704088"/>
-              <a:gd name="connsiteY0" fmla="*/ 29760 h 119040"/>
-              <a:gd name="connsiteX1" fmla="*/ 612090 w 704088"/>
-              <a:gd name="connsiteY1" fmla="*/ 29760 h 119040"/>
-              <a:gd name="connsiteX2" fmla="*/ 612090 w 704088"/>
-              <a:gd name="connsiteY2" fmla="*/ 0 h 119040"/>
-              <a:gd name="connsiteX3" fmla="*/ 704088 w 704088"/>
-              <a:gd name="connsiteY3" fmla="*/ 59520 h 119040"/>
-              <a:gd name="connsiteX4" fmla="*/ 612090 w 704088"/>
-              <a:gd name="connsiteY4" fmla="*/ 119040 h 119040"/>
-              <a:gd name="connsiteX5" fmla="*/ 612090 w 704088"/>
-              <a:gd name="connsiteY5" fmla="*/ 89280 h 119040"/>
-              <a:gd name="connsiteX6" fmla="*/ 0 w 704088"/>
-              <a:gd name="connsiteY6" fmla="*/ 89280 h 119040"/>
-              <a:gd name="connsiteX7" fmla="*/ 0 w 704088"/>
-              <a:gd name="connsiteY7" fmla="*/ 29760 h 119040"/>
-              <a:gd name="connsiteX0" fmla="*/ 22225 w 726313"/>
-              <a:gd name="connsiteY0" fmla="*/ 29760 h 119040"/>
-              <a:gd name="connsiteX1" fmla="*/ 634315 w 726313"/>
-              <a:gd name="connsiteY1" fmla="*/ 29760 h 119040"/>
-              <a:gd name="connsiteX2" fmla="*/ 634315 w 726313"/>
-              <a:gd name="connsiteY2" fmla="*/ 0 h 119040"/>
-              <a:gd name="connsiteX3" fmla="*/ 726313 w 726313"/>
-              <a:gd name="connsiteY3" fmla="*/ 59520 h 119040"/>
-              <a:gd name="connsiteX4" fmla="*/ 634315 w 726313"/>
-              <a:gd name="connsiteY4" fmla="*/ 119040 h 119040"/>
-              <a:gd name="connsiteX5" fmla="*/ 634315 w 726313"/>
-              <a:gd name="connsiteY5" fmla="*/ 89280 h 119040"/>
-              <a:gd name="connsiteX6" fmla="*/ 0 w 726313"/>
-              <a:gd name="connsiteY6" fmla="*/ 92455 h 119040"/>
-              <a:gd name="connsiteX7" fmla="*/ 22225 w 726313"/>
-              <a:gd name="connsiteY7" fmla="*/ 29760 h 119040"/>
-              <a:gd name="connsiteX0" fmla="*/ 0 w 726313"/>
-              <a:gd name="connsiteY0" fmla="*/ 29760 h 119040"/>
-              <a:gd name="connsiteX1" fmla="*/ 634315 w 726313"/>
-              <a:gd name="connsiteY1" fmla="*/ 29760 h 119040"/>
-              <a:gd name="connsiteX2" fmla="*/ 634315 w 726313"/>
-              <a:gd name="connsiteY2" fmla="*/ 0 h 119040"/>
-              <a:gd name="connsiteX3" fmla="*/ 726313 w 726313"/>
-              <a:gd name="connsiteY3" fmla="*/ 59520 h 119040"/>
-              <a:gd name="connsiteX4" fmla="*/ 634315 w 726313"/>
-              <a:gd name="connsiteY4" fmla="*/ 119040 h 119040"/>
-              <a:gd name="connsiteX5" fmla="*/ 634315 w 726313"/>
-              <a:gd name="connsiteY5" fmla="*/ 89280 h 119040"/>
-              <a:gd name="connsiteX6" fmla="*/ 0 w 726313"/>
-              <a:gd name="connsiteY6" fmla="*/ 92455 h 119040"/>
-              <a:gd name="connsiteX7" fmla="*/ 0 w 726313"/>
-              <a:gd name="connsiteY7" fmla="*/ 29760 h 119040"/>
-            </a:gdLst>
-            <a:ahLst/>
-            <a:cxnLst>
-              <a:cxn ang="0">
-                <a:pos x="connsiteX0" y="connsiteY0"/>
-              </a:cxn>
-              <a:cxn ang="0">
-                <a:pos x="connsiteX1" y="connsiteY1"/>
-              </a:cxn>
-              <a:cxn ang="0">
-                <a:pos x="connsiteX2" y="connsiteY2"/>
-              </a:cxn>
-              <a:cxn ang="0">
-                <a:pos x="connsiteX3" y="connsiteY3"/>
-              </a:cxn>
-              <a:cxn ang="0">
-                <a:pos x="connsiteX4" y="connsiteY4"/>
-              </a:cxn>
-              <a:cxn ang="0">
-                <a:pos x="connsiteX5" y="connsiteY5"/>
-              </a:cxn>
-              <a:cxn ang="0">
-                <a:pos x="connsiteX6" y="connsiteY6"/>
-              </a:cxn>
-              <a:cxn ang="0">
-                <a:pos x="connsiteX7" y="connsiteY7"/>
-              </a:cxn>
-            </a:cxnLst>
-            <a:rect l="l" t="t" r="r" b="b"/>
-            <a:pathLst>
-              <a:path w="726313" h="119040">
-                <a:moveTo>
-                  <a:pt x="0" y="29760"/>
-                </a:moveTo>
-                <a:lnTo>
-                  <a:pt x="634315" y="29760"/>
-                </a:lnTo>
-                <a:lnTo>
-                  <a:pt x="634315" y="0"/>
-                </a:lnTo>
-                <a:lnTo>
-                  <a:pt x="726313" y="59520"/>
-                </a:lnTo>
-                <a:lnTo>
-                  <a:pt x="634315" y="119040"/>
-                </a:lnTo>
-                <a:lnTo>
-                  <a:pt x="634315" y="89280"/>
-                </a:lnTo>
-                <a:lnTo>
-                  <a:pt x="0" y="92455"/>
-                </a:lnTo>
-                <a:lnTo>
-                  <a:pt x="0" y="29760"/>
-                </a:lnTo>
-                <a:close/>
-              </a:path>
-            </a:pathLst>
-          </a:custGeom>
+          </a:prstGeom>
           <a:solidFill>
             <a:schemeClr val="accent2">
               <a:lumMod val="60000"/>
@@ -1514,195 +1407,12 @@
         </p:nvSpPr>
         <p:spPr>
           <a:xfrm>
-            <a:off x="4640263" y="2892054"/>
-            <a:ext cx="704774" cy="64008"/>
+            <a:off x="4773613" y="2892054"/>
+            <a:ext cx="586800" cy="64008"/>
           </a:xfrm>
-          <a:custGeom>
+          <a:prstGeom prst="leftRightArrow">
             <a:avLst/>
-            <a:gdLst>
-              <a:gd name="connsiteX0" fmla="*/ 0 w 649224"/>
-              <a:gd name="connsiteY0" fmla="*/ 32004 h 64008"/>
-              <a:gd name="connsiteX1" fmla="*/ 42875 w 649224"/>
-              <a:gd name="connsiteY1" fmla="*/ 0 h 64008"/>
-              <a:gd name="connsiteX2" fmla="*/ 42875 w 649224"/>
-              <a:gd name="connsiteY2" fmla="*/ 17314 h 64008"/>
-              <a:gd name="connsiteX3" fmla="*/ 606349 w 649224"/>
-              <a:gd name="connsiteY3" fmla="*/ 17314 h 64008"/>
-              <a:gd name="connsiteX4" fmla="*/ 606349 w 649224"/>
-              <a:gd name="connsiteY4" fmla="*/ 0 h 64008"/>
-              <a:gd name="connsiteX5" fmla="*/ 649224 w 649224"/>
-              <a:gd name="connsiteY5" fmla="*/ 32004 h 64008"/>
-              <a:gd name="connsiteX6" fmla="*/ 606349 w 649224"/>
-              <a:gd name="connsiteY6" fmla="*/ 64008 h 64008"/>
-              <a:gd name="connsiteX7" fmla="*/ 606349 w 649224"/>
-              <a:gd name="connsiteY7" fmla="*/ 46694 h 64008"/>
-              <a:gd name="connsiteX8" fmla="*/ 42875 w 649224"/>
-              <a:gd name="connsiteY8" fmla="*/ 46694 h 64008"/>
-              <a:gd name="connsiteX9" fmla="*/ 42875 w 649224"/>
-              <a:gd name="connsiteY9" fmla="*/ 64008 h 64008"/>
-              <a:gd name="connsiteX10" fmla="*/ 0 w 649224"/>
-              <a:gd name="connsiteY10" fmla="*/ 32004 h 64008"/>
-              <a:gd name="connsiteX0" fmla="*/ 0 w 606349"/>
-              <a:gd name="connsiteY0" fmla="*/ 64008 h 64008"/>
-              <a:gd name="connsiteX1" fmla="*/ 0 w 606349"/>
-              <a:gd name="connsiteY1" fmla="*/ 0 h 64008"/>
-              <a:gd name="connsiteX2" fmla="*/ 0 w 606349"/>
-              <a:gd name="connsiteY2" fmla="*/ 17314 h 64008"/>
-              <a:gd name="connsiteX3" fmla="*/ 563474 w 606349"/>
-              <a:gd name="connsiteY3" fmla="*/ 17314 h 64008"/>
-              <a:gd name="connsiteX4" fmla="*/ 563474 w 606349"/>
-              <a:gd name="connsiteY4" fmla="*/ 0 h 64008"/>
-              <a:gd name="connsiteX5" fmla="*/ 606349 w 606349"/>
-              <a:gd name="connsiteY5" fmla="*/ 32004 h 64008"/>
-              <a:gd name="connsiteX6" fmla="*/ 563474 w 606349"/>
-              <a:gd name="connsiteY6" fmla="*/ 64008 h 64008"/>
-              <a:gd name="connsiteX7" fmla="*/ 563474 w 606349"/>
-              <a:gd name="connsiteY7" fmla="*/ 46694 h 64008"/>
-              <a:gd name="connsiteX8" fmla="*/ 0 w 606349"/>
-              <a:gd name="connsiteY8" fmla="*/ 46694 h 64008"/>
-              <a:gd name="connsiteX9" fmla="*/ 0 w 606349"/>
-              <a:gd name="connsiteY9" fmla="*/ 64008 h 64008"/>
-              <a:gd name="connsiteX0" fmla="*/ 0 w 606349"/>
-              <a:gd name="connsiteY0" fmla="*/ 64008 h 64008"/>
-              <a:gd name="connsiteX1" fmla="*/ 0 w 606349"/>
-              <a:gd name="connsiteY1" fmla="*/ 17314 h 64008"/>
-              <a:gd name="connsiteX2" fmla="*/ 563474 w 606349"/>
-              <a:gd name="connsiteY2" fmla="*/ 17314 h 64008"/>
-              <a:gd name="connsiteX3" fmla="*/ 563474 w 606349"/>
-              <a:gd name="connsiteY3" fmla="*/ 0 h 64008"/>
-              <a:gd name="connsiteX4" fmla="*/ 606349 w 606349"/>
-              <a:gd name="connsiteY4" fmla="*/ 32004 h 64008"/>
-              <a:gd name="connsiteX5" fmla="*/ 563474 w 606349"/>
-              <a:gd name="connsiteY5" fmla="*/ 64008 h 64008"/>
-              <a:gd name="connsiteX6" fmla="*/ 563474 w 606349"/>
-              <a:gd name="connsiteY6" fmla="*/ 46694 h 64008"/>
-              <a:gd name="connsiteX7" fmla="*/ 0 w 606349"/>
-              <a:gd name="connsiteY7" fmla="*/ 46694 h 64008"/>
-              <a:gd name="connsiteX8" fmla="*/ 0 w 606349"/>
-              <a:gd name="connsiteY8" fmla="*/ 64008 h 64008"/>
-              <a:gd name="connsiteX0" fmla="*/ 0 w 606349"/>
-              <a:gd name="connsiteY0" fmla="*/ 46694 h 64008"/>
-              <a:gd name="connsiteX1" fmla="*/ 0 w 606349"/>
-              <a:gd name="connsiteY1" fmla="*/ 17314 h 64008"/>
-              <a:gd name="connsiteX2" fmla="*/ 563474 w 606349"/>
-              <a:gd name="connsiteY2" fmla="*/ 17314 h 64008"/>
-              <a:gd name="connsiteX3" fmla="*/ 563474 w 606349"/>
-              <a:gd name="connsiteY3" fmla="*/ 0 h 64008"/>
-              <a:gd name="connsiteX4" fmla="*/ 606349 w 606349"/>
-              <a:gd name="connsiteY4" fmla="*/ 32004 h 64008"/>
-              <a:gd name="connsiteX5" fmla="*/ 563474 w 606349"/>
-              <a:gd name="connsiteY5" fmla="*/ 64008 h 64008"/>
-              <a:gd name="connsiteX6" fmla="*/ 563474 w 606349"/>
-              <a:gd name="connsiteY6" fmla="*/ 46694 h 64008"/>
-              <a:gd name="connsiteX7" fmla="*/ 0 w 606349"/>
-              <a:gd name="connsiteY7" fmla="*/ 46694 h 64008"/>
-              <a:gd name="connsiteX0" fmla="*/ 76200 w 682549"/>
-              <a:gd name="connsiteY0" fmla="*/ 46694 h 64008"/>
-              <a:gd name="connsiteX1" fmla="*/ 0 w 682549"/>
-              <a:gd name="connsiteY1" fmla="*/ 20489 h 64008"/>
-              <a:gd name="connsiteX2" fmla="*/ 639674 w 682549"/>
-              <a:gd name="connsiteY2" fmla="*/ 17314 h 64008"/>
-              <a:gd name="connsiteX3" fmla="*/ 639674 w 682549"/>
-              <a:gd name="connsiteY3" fmla="*/ 0 h 64008"/>
-              <a:gd name="connsiteX4" fmla="*/ 682549 w 682549"/>
-              <a:gd name="connsiteY4" fmla="*/ 32004 h 64008"/>
-              <a:gd name="connsiteX5" fmla="*/ 639674 w 682549"/>
-              <a:gd name="connsiteY5" fmla="*/ 64008 h 64008"/>
-              <a:gd name="connsiteX6" fmla="*/ 639674 w 682549"/>
-              <a:gd name="connsiteY6" fmla="*/ 46694 h 64008"/>
-              <a:gd name="connsiteX7" fmla="*/ 76200 w 682549"/>
-              <a:gd name="connsiteY7" fmla="*/ 46694 h 64008"/>
-              <a:gd name="connsiteX0" fmla="*/ 0 w 698424"/>
-              <a:gd name="connsiteY0" fmla="*/ 46694 h 64008"/>
-              <a:gd name="connsiteX1" fmla="*/ 15875 w 698424"/>
-              <a:gd name="connsiteY1" fmla="*/ 20489 h 64008"/>
-              <a:gd name="connsiteX2" fmla="*/ 655549 w 698424"/>
-              <a:gd name="connsiteY2" fmla="*/ 17314 h 64008"/>
-              <a:gd name="connsiteX3" fmla="*/ 655549 w 698424"/>
-              <a:gd name="connsiteY3" fmla="*/ 0 h 64008"/>
-              <a:gd name="connsiteX4" fmla="*/ 698424 w 698424"/>
-              <a:gd name="connsiteY4" fmla="*/ 32004 h 64008"/>
-              <a:gd name="connsiteX5" fmla="*/ 655549 w 698424"/>
-              <a:gd name="connsiteY5" fmla="*/ 64008 h 64008"/>
-              <a:gd name="connsiteX6" fmla="*/ 655549 w 698424"/>
-              <a:gd name="connsiteY6" fmla="*/ 46694 h 64008"/>
-              <a:gd name="connsiteX7" fmla="*/ 0 w 698424"/>
-              <a:gd name="connsiteY7" fmla="*/ 46694 h 64008"/>
-              <a:gd name="connsiteX0" fmla="*/ 6350 w 704774"/>
-              <a:gd name="connsiteY0" fmla="*/ 46694 h 64008"/>
-              <a:gd name="connsiteX1" fmla="*/ 0 w 704774"/>
-              <a:gd name="connsiteY1" fmla="*/ 20489 h 64008"/>
-              <a:gd name="connsiteX2" fmla="*/ 661899 w 704774"/>
-              <a:gd name="connsiteY2" fmla="*/ 17314 h 64008"/>
-              <a:gd name="connsiteX3" fmla="*/ 661899 w 704774"/>
-              <a:gd name="connsiteY3" fmla="*/ 0 h 64008"/>
-              <a:gd name="connsiteX4" fmla="*/ 704774 w 704774"/>
-              <a:gd name="connsiteY4" fmla="*/ 32004 h 64008"/>
-              <a:gd name="connsiteX5" fmla="*/ 661899 w 704774"/>
-              <a:gd name="connsiteY5" fmla="*/ 64008 h 64008"/>
-              <a:gd name="connsiteX6" fmla="*/ 661899 w 704774"/>
-              <a:gd name="connsiteY6" fmla="*/ 46694 h 64008"/>
-              <a:gd name="connsiteX7" fmla="*/ 6350 w 704774"/>
-              <a:gd name="connsiteY7" fmla="*/ 46694 h 64008"/>
-            </a:gdLst>
-            <a:ahLst/>
-            <a:cxnLst>
-              <a:cxn ang="0">
-                <a:pos x="connsiteX0" y="connsiteY0"/>
-              </a:cxn>
-              <a:cxn ang="0">
-                <a:pos x="connsiteX1" y="connsiteY1"/>
-              </a:cxn>
-              <a:cxn ang="0">
-                <a:pos x="connsiteX2" y="connsiteY2"/>
-              </a:cxn>
-              <a:cxn ang="0">
-                <a:pos x="connsiteX3" y="connsiteY3"/>
-              </a:cxn>
-              <a:cxn ang="0">
-                <a:pos x="connsiteX4" y="connsiteY4"/>
-              </a:cxn>
-              <a:cxn ang="0">
-                <a:pos x="connsiteX5" y="connsiteY5"/>
-              </a:cxn>
-              <a:cxn ang="0">
-                <a:pos x="connsiteX6" y="connsiteY6"/>
-              </a:cxn>
-              <a:cxn ang="0">
-                <a:pos x="connsiteX7" y="connsiteY7"/>
-              </a:cxn>
-            </a:cxnLst>
-            <a:rect l="l" t="t" r="r" b="b"/>
-            <a:pathLst>
-              <a:path w="704774" h="64008">
-                <a:moveTo>
-                  <a:pt x="6350" y="46694"/>
-                </a:moveTo>
-                <a:lnTo>
-                  <a:pt x="0" y="20489"/>
-                </a:lnTo>
-                <a:lnTo>
-                  <a:pt x="661899" y="17314"/>
-                </a:lnTo>
-                <a:lnTo>
-                  <a:pt x="661899" y="0"/>
-                </a:lnTo>
-                <a:lnTo>
-                  <a:pt x="704774" y="32004"/>
-                </a:lnTo>
-                <a:lnTo>
-                  <a:pt x="661899" y="64008"/>
-                </a:lnTo>
-                <a:lnTo>
-                  <a:pt x="661899" y="46694"/>
-                </a:lnTo>
-                <a:lnTo>
-                  <a:pt x="6350" y="46694"/>
-                </a:lnTo>
-                <a:close/>
-              </a:path>
-            </a:pathLst>
-          </a:custGeom>
+          </a:prstGeom>
           <a:solidFill>
             <a:schemeClr val="accent4">
               <a:lumMod val="40000"/>
@@ -1753,9 +1463,9 @@
         <p:grpSpPr>
           <a:xfrm>
             <a:off x="5390764" y="2465705"/>
-            <a:ext cx="1383161" cy="814119"/>
+            <a:ext cx="1383161" cy="803733"/>
             <a:chOff x="5668803" y="2309053"/>
-            <a:chExt cx="1838831" cy="1165660"/>
+            <a:chExt cx="1838831" cy="1150789"/>
           </a:xfrm>
           <a:effectLst>
             <a:outerShdw blurRad="50800" dist="50800" dir="2700000" sx="98239" sy="98239" algn="tl" rotWithShape="0">
@@ -3737,8 +3447,8 @@
           </p:nvSpPr>
           <p:spPr>
             <a:xfrm>
-              <a:off x="6180711" y="2558243"/>
-              <a:ext cx="891590" cy="916470"/>
+              <a:off x="6078106" y="2558243"/>
+              <a:ext cx="1198103" cy="749149"/>
             </a:xfrm>
             <a:prstGeom prst="rect">
               <a:avLst/>
@@ -3790,275 +3500,16 @@
         </p:nvSpPr>
         <p:spPr>
           <a:xfrm>
-            <a:off x="4649532" y="3277812"/>
-            <a:ext cx="1363841" cy="675896"/>
+            <a:off x="4757928" y="3278301"/>
+            <a:ext cx="1211001" cy="705704"/>
           </a:xfrm>
-          <a:custGeom>
-            <a:avLst/>
-            <a:gdLst>
-              <a:gd name="connsiteX0" fmla="*/ 0 w 1341260"/>
-              <a:gd name="connsiteY0" fmla="*/ 643296 h 706321"/>
-              <a:gd name="connsiteX1" fmla="*/ 94894 w 1341260"/>
-              <a:gd name="connsiteY1" fmla="*/ 580271 h 706321"/>
-              <a:gd name="connsiteX2" fmla="*/ 94894 w 1341260"/>
-              <a:gd name="connsiteY2" fmla="*/ 613871 h 706321"/>
-              <a:gd name="connsiteX3" fmla="*/ 1248810 w 1341260"/>
-              <a:gd name="connsiteY3" fmla="*/ 613871 h 706321"/>
-              <a:gd name="connsiteX4" fmla="*/ 1248810 w 1341260"/>
-              <a:gd name="connsiteY4" fmla="*/ 94894 h 706321"/>
-              <a:gd name="connsiteX5" fmla="*/ 1215210 w 1341260"/>
-              <a:gd name="connsiteY5" fmla="*/ 94894 h 706321"/>
-              <a:gd name="connsiteX6" fmla="*/ 1278235 w 1341260"/>
-              <a:gd name="connsiteY6" fmla="*/ 0 h 706321"/>
-              <a:gd name="connsiteX7" fmla="*/ 1341260 w 1341260"/>
-              <a:gd name="connsiteY7" fmla="*/ 94894 h 706321"/>
-              <a:gd name="connsiteX8" fmla="*/ 1307660 w 1341260"/>
-              <a:gd name="connsiteY8" fmla="*/ 94894 h 706321"/>
-              <a:gd name="connsiteX9" fmla="*/ 1307660 w 1341260"/>
-              <a:gd name="connsiteY9" fmla="*/ 672721 h 706321"/>
-              <a:gd name="connsiteX10" fmla="*/ 94894 w 1341260"/>
-              <a:gd name="connsiteY10" fmla="*/ 672721 h 706321"/>
-              <a:gd name="connsiteX11" fmla="*/ 94894 w 1341260"/>
-              <a:gd name="connsiteY11" fmla="*/ 706321 h 706321"/>
-              <a:gd name="connsiteX12" fmla="*/ 0 w 1341260"/>
-              <a:gd name="connsiteY12" fmla="*/ 643296 h 706321"/>
-              <a:gd name="connsiteX0" fmla="*/ 0 w 1246366"/>
-              <a:gd name="connsiteY0" fmla="*/ 706321 h 706321"/>
-              <a:gd name="connsiteX1" fmla="*/ 0 w 1246366"/>
-              <a:gd name="connsiteY1" fmla="*/ 580271 h 706321"/>
-              <a:gd name="connsiteX2" fmla="*/ 0 w 1246366"/>
-              <a:gd name="connsiteY2" fmla="*/ 613871 h 706321"/>
-              <a:gd name="connsiteX3" fmla="*/ 1153916 w 1246366"/>
-              <a:gd name="connsiteY3" fmla="*/ 613871 h 706321"/>
-              <a:gd name="connsiteX4" fmla="*/ 1153916 w 1246366"/>
-              <a:gd name="connsiteY4" fmla="*/ 94894 h 706321"/>
-              <a:gd name="connsiteX5" fmla="*/ 1120316 w 1246366"/>
-              <a:gd name="connsiteY5" fmla="*/ 94894 h 706321"/>
-              <a:gd name="connsiteX6" fmla="*/ 1183341 w 1246366"/>
-              <a:gd name="connsiteY6" fmla="*/ 0 h 706321"/>
-              <a:gd name="connsiteX7" fmla="*/ 1246366 w 1246366"/>
-              <a:gd name="connsiteY7" fmla="*/ 94894 h 706321"/>
-              <a:gd name="connsiteX8" fmla="*/ 1212766 w 1246366"/>
-              <a:gd name="connsiteY8" fmla="*/ 94894 h 706321"/>
-              <a:gd name="connsiteX9" fmla="*/ 1212766 w 1246366"/>
-              <a:gd name="connsiteY9" fmla="*/ 672721 h 706321"/>
-              <a:gd name="connsiteX10" fmla="*/ 0 w 1246366"/>
-              <a:gd name="connsiteY10" fmla="*/ 672721 h 706321"/>
-              <a:gd name="connsiteX11" fmla="*/ 0 w 1246366"/>
-              <a:gd name="connsiteY11" fmla="*/ 706321 h 706321"/>
-              <a:gd name="connsiteX0" fmla="*/ 0 w 1246366"/>
-              <a:gd name="connsiteY0" fmla="*/ 706321 h 706321"/>
-              <a:gd name="connsiteX1" fmla="*/ 0 w 1246366"/>
-              <a:gd name="connsiteY1" fmla="*/ 613871 h 706321"/>
-              <a:gd name="connsiteX2" fmla="*/ 1153916 w 1246366"/>
-              <a:gd name="connsiteY2" fmla="*/ 613871 h 706321"/>
-              <a:gd name="connsiteX3" fmla="*/ 1153916 w 1246366"/>
-              <a:gd name="connsiteY3" fmla="*/ 94894 h 706321"/>
-              <a:gd name="connsiteX4" fmla="*/ 1120316 w 1246366"/>
-              <a:gd name="connsiteY4" fmla="*/ 94894 h 706321"/>
-              <a:gd name="connsiteX5" fmla="*/ 1183341 w 1246366"/>
-              <a:gd name="connsiteY5" fmla="*/ 0 h 706321"/>
-              <a:gd name="connsiteX6" fmla="*/ 1246366 w 1246366"/>
-              <a:gd name="connsiteY6" fmla="*/ 94894 h 706321"/>
-              <a:gd name="connsiteX7" fmla="*/ 1212766 w 1246366"/>
-              <a:gd name="connsiteY7" fmla="*/ 94894 h 706321"/>
-              <a:gd name="connsiteX8" fmla="*/ 1212766 w 1246366"/>
-              <a:gd name="connsiteY8" fmla="*/ 672721 h 706321"/>
-              <a:gd name="connsiteX9" fmla="*/ 0 w 1246366"/>
-              <a:gd name="connsiteY9" fmla="*/ 672721 h 706321"/>
-              <a:gd name="connsiteX10" fmla="*/ 0 w 1246366"/>
-              <a:gd name="connsiteY10" fmla="*/ 706321 h 706321"/>
-              <a:gd name="connsiteX0" fmla="*/ 0 w 1246366"/>
-              <a:gd name="connsiteY0" fmla="*/ 672721 h 672721"/>
-              <a:gd name="connsiteX1" fmla="*/ 0 w 1246366"/>
-              <a:gd name="connsiteY1" fmla="*/ 613871 h 672721"/>
-              <a:gd name="connsiteX2" fmla="*/ 1153916 w 1246366"/>
-              <a:gd name="connsiteY2" fmla="*/ 613871 h 672721"/>
-              <a:gd name="connsiteX3" fmla="*/ 1153916 w 1246366"/>
-              <a:gd name="connsiteY3" fmla="*/ 94894 h 672721"/>
-              <a:gd name="connsiteX4" fmla="*/ 1120316 w 1246366"/>
-              <a:gd name="connsiteY4" fmla="*/ 94894 h 672721"/>
-              <a:gd name="connsiteX5" fmla="*/ 1183341 w 1246366"/>
-              <a:gd name="connsiteY5" fmla="*/ 0 h 672721"/>
-              <a:gd name="connsiteX6" fmla="*/ 1246366 w 1246366"/>
-              <a:gd name="connsiteY6" fmla="*/ 94894 h 672721"/>
-              <a:gd name="connsiteX7" fmla="*/ 1212766 w 1246366"/>
-              <a:gd name="connsiteY7" fmla="*/ 94894 h 672721"/>
-              <a:gd name="connsiteX8" fmla="*/ 1212766 w 1246366"/>
-              <a:gd name="connsiteY8" fmla="*/ 672721 h 672721"/>
-              <a:gd name="connsiteX9" fmla="*/ 0 w 1246366"/>
-              <a:gd name="connsiteY9" fmla="*/ 672721 h 672721"/>
-              <a:gd name="connsiteX0" fmla="*/ 127000 w 1373366"/>
-              <a:gd name="connsiteY0" fmla="*/ 672721 h 672721"/>
-              <a:gd name="connsiteX1" fmla="*/ 0 w 1373366"/>
-              <a:gd name="connsiteY1" fmla="*/ 613871 h 672721"/>
-              <a:gd name="connsiteX2" fmla="*/ 1280916 w 1373366"/>
-              <a:gd name="connsiteY2" fmla="*/ 613871 h 672721"/>
-              <a:gd name="connsiteX3" fmla="*/ 1280916 w 1373366"/>
-              <a:gd name="connsiteY3" fmla="*/ 94894 h 672721"/>
-              <a:gd name="connsiteX4" fmla="*/ 1247316 w 1373366"/>
-              <a:gd name="connsiteY4" fmla="*/ 94894 h 672721"/>
-              <a:gd name="connsiteX5" fmla="*/ 1310341 w 1373366"/>
-              <a:gd name="connsiteY5" fmla="*/ 0 h 672721"/>
-              <a:gd name="connsiteX6" fmla="*/ 1373366 w 1373366"/>
-              <a:gd name="connsiteY6" fmla="*/ 94894 h 672721"/>
-              <a:gd name="connsiteX7" fmla="*/ 1339766 w 1373366"/>
-              <a:gd name="connsiteY7" fmla="*/ 94894 h 672721"/>
-              <a:gd name="connsiteX8" fmla="*/ 1339766 w 1373366"/>
-              <a:gd name="connsiteY8" fmla="*/ 672721 h 672721"/>
-              <a:gd name="connsiteX9" fmla="*/ 127000 w 1373366"/>
-              <a:gd name="connsiteY9" fmla="*/ 672721 h 672721"/>
-              <a:gd name="connsiteX0" fmla="*/ 107950 w 1354316"/>
-              <a:gd name="connsiteY0" fmla="*/ 672721 h 672721"/>
-              <a:gd name="connsiteX1" fmla="*/ 0 w 1354316"/>
-              <a:gd name="connsiteY1" fmla="*/ 617046 h 672721"/>
-              <a:gd name="connsiteX2" fmla="*/ 1261866 w 1354316"/>
-              <a:gd name="connsiteY2" fmla="*/ 613871 h 672721"/>
-              <a:gd name="connsiteX3" fmla="*/ 1261866 w 1354316"/>
-              <a:gd name="connsiteY3" fmla="*/ 94894 h 672721"/>
-              <a:gd name="connsiteX4" fmla="*/ 1228266 w 1354316"/>
-              <a:gd name="connsiteY4" fmla="*/ 94894 h 672721"/>
-              <a:gd name="connsiteX5" fmla="*/ 1291291 w 1354316"/>
-              <a:gd name="connsiteY5" fmla="*/ 0 h 672721"/>
-              <a:gd name="connsiteX6" fmla="*/ 1354316 w 1354316"/>
-              <a:gd name="connsiteY6" fmla="*/ 94894 h 672721"/>
-              <a:gd name="connsiteX7" fmla="*/ 1320716 w 1354316"/>
-              <a:gd name="connsiteY7" fmla="*/ 94894 h 672721"/>
-              <a:gd name="connsiteX8" fmla="*/ 1320716 w 1354316"/>
-              <a:gd name="connsiteY8" fmla="*/ 672721 h 672721"/>
-              <a:gd name="connsiteX9" fmla="*/ 107950 w 1354316"/>
-              <a:gd name="connsiteY9" fmla="*/ 672721 h 672721"/>
-              <a:gd name="connsiteX0" fmla="*/ 0 w 1360666"/>
-              <a:gd name="connsiteY0" fmla="*/ 675896 h 675896"/>
-              <a:gd name="connsiteX1" fmla="*/ 6350 w 1360666"/>
-              <a:gd name="connsiteY1" fmla="*/ 617046 h 675896"/>
-              <a:gd name="connsiteX2" fmla="*/ 1268216 w 1360666"/>
-              <a:gd name="connsiteY2" fmla="*/ 613871 h 675896"/>
-              <a:gd name="connsiteX3" fmla="*/ 1268216 w 1360666"/>
-              <a:gd name="connsiteY3" fmla="*/ 94894 h 675896"/>
-              <a:gd name="connsiteX4" fmla="*/ 1234616 w 1360666"/>
-              <a:gd name="connsiteY4" fmla="*/ 94894 h 675896"/>
-              <a:gd name="connsiteX5" fmla="*/ 1297641 w 1360666"/>
-              <a:gd name="connsiteY5" fmla="*/ 0 h 675896"/>
-              <a:gd name="connsiteX6" fmla="*/ 1360666 w 1360666"/>
-              <a:gd name="connsiteY6" fmla="*/ 94894 h 675896"/>
-              <a:gd name="connsiteX7" fmla="*/ 1327066 w 1360666"/>
-              <a:gd name="connsiteY7" fmla="*/ 94894 h 675896"/>
-              <a:gd name="connsiteX8" fmla="*/ 1327066 w 1360666"/>
-              <a:gd name="connsiteY8" fmla="*/ 672721 h 675896"/>
-              <a:gd name="connsiteX9" fmla="*/ 0 w 1360666"/>
-              <a:gd name="connsiteY9" fmla="*/ 675896 h 675896"/>
-              <a:gd name="connsiteX0" fmla="*/ 9525 w 1370191"/>
-              <a:gd name="connsiteY0" fmla="*/ 675896 h 675896"/>
-              <a:gd name="connsiteX1" fmla="*/ 0 w 1370191"/>
-              <a:gd name="connsiteY1" fmla="*/ 617046 h 675896"/>
-              <a:gd name="connsiteX2" fmla="*/ 1277741 w 1370191"/>
-              <a:gd name="connsiteY2" fmla="*/ 613871 h 675896"/>
-              <a:gd name="connsiteX3" fmla="*/ 1277741 w 1370191"/>
-              <a:gd name="connsiteY3" fmla="*/ 94894 h 675896"/>
-              <a:gd name="connsiteX4" fmla="*/ 1244141 w 1370191"/>
-              <a:gd name="connsiteY4" fmla="*/ 94894 h 675896"/>
-              <a:gd name="connsiteX5" fmla="*/ 1307166 w 1370191"/>
-              <a:gd name="connsiteY5" fmla="*/ 0 h 675896"/>
-              <a:gd name="connsiteX6" fmla="*/ 1370191 w 1370191"/>
-              <a:gd name="connsiteY6" fmla="*/ 94894 h 675896"/>
-              <a:gd name="connsiteX7" fmla="*/ 1336591 w 1370191"/>
-              <a:gd name="connsiteY7" fmla="*/ 94894 h 675896"/>
-              <a:gd name="connsiteX8" fmla="*/ 1336591 w 1370191"/>
-              <a:gd name="connsiteY8" fmla="*/ 672721 h 675896"/>
-              <a:gd name="connsiteX9" fmla="*/ 9525 w 1370191"/>
-              <a:gd name="connsiteY9" fmla="*/ 675896 h 675896"/>
-              <a:gd name="connsiteX0" fmla="*/ 3175 w 1363841"/>
-              <a:gd name="connsiteY0" fmla="*/ 675896 h 675896"/>
-              <a:gd name="connsiteX1" fmla="*/ 0 w 1363841"/>
-              <a:gd name="connsiteY1" fmla="*/ 617046 h 675896"/>
-              <a:gd name="connsiteX2" fmla="*/ 1271391 w 1363841"/>
-              <a:gd name="connsiteY2" fmla="*/ 613871 h 675896"/>
-              <a:gd name="connsiteX3" fmla="*/ 1271391 w 1363841"/>
-              <a:gd name="connsiteY3" fmla="*/ 94894 h 675896"/>
-              <a:gd name="connsiteX4" fmla="*/ 1237791 w 1363841"/>
-              <a:gd name="connsiteY4" fmla="*/ 94894 h 675896"/>
-              <a:gd name="connsiteX5" fmla="*/ 1300816 w 1363841"/>
-              <a:gd name="connsiteY5" fmla="*/ 0 h 675896"/>
-              <a:gd name="connsiteX6" fmla="*/ 1363841 w 1363841"/>
-              <a:gd name="connsiteY6" fmla="*/ 94894 h 675896"/>
-              <a:gd name="connsiteX7" fmla="*/ 1330241 w 1363841"/>
-              <a:gd name="connsiteY7" fmla="*/ 94894 h 675896"/>
-              <a:gd name="connsiteX8" fmla="*/ 1330241 w 1363841"/>
-              <a:gd name="connsiteY8" fmla="*/ 672721 h 675896"/>
-              <a:gd name="connsiteX9" fmla="*/ 3175 w 1363841"/>
-              <a:gd name="connsiteY9" fmla="*/ 675896 h 675896"/>
-            </a:gdLst>
-            <a:ahLst/>
-            <a:cxnLst>
-              <a:cxn ang="0">
-                <a:pos x="connsiteX0" y="connsiteY0"/>
-              </a:cxn>
-              <a:cxn ang="0">
-                <a:pos x="connsiteX1" y="connsiteY1"/>
-              </a:cxn>
-              <a:cxn ang="0">
-                <a:pos x="connsiteX2" y="connsiteY2"/>
-              </a:cxn>
-              <a:cxn ang="0">
-                <a:pos x="connsiteX3" y="connsiteY3"/>
-              </a:cxn>
-              <a:cxn ang="0">
-                <a:pos x="connsiteX4" y="connsiteY4"/>
-              </a:cxn>
-              <a:cxn ang="0">
-                <a:pos x="connsiteX5" y="connsiteY5"/>
-              </a:cxn>
-              <a:cxn ang="0">
-                <a:pos x="connsiteX6" y="connsiteY6"/>
-              </a:cxn>
-              <a:cxn ang="0">
-                <a:pos x="connsiteX7" y="connsiteY7"/>
-              </a:cxn>
-              <a:cxn ang="0">
-                <a:pos x="connsiteX8" y="connsiteY8"/>
-              </a:cxn>
-              <a:cxn ang="0">
-                <a:pos x="connsiteX9" y="connsiteY9"/>
-              </a:cxn>
-            </a:cxnLst>
-            <a:rect l="l" t="t" r="r" b="b"/>
-            <a:pathLst>
-              <a:path w="1363841" h="675896">
-                <a:moveTo>
-                  <a:pt x="3175" y="675896"/>
-                </a:moveTo>
-                <a:lnTo>
-                  <a:pt x="0" y="617046"/>
-                </a:lnTo>
-                <a:lnTo>
-                  <a:pt x="1271391" y="613871"/>
-                </a:lnTo>
-                <a:lnTo>
-                  <a:pt x="1271391" y="94894"/>
-                </a:lnTo>
-                <a:lnTo>
-                  <a:pt x="1237791" y="94894"/>
-                </a:lnTo>
-                <a:lnTo>
-                  <a:pt x="1300816" y="0"/>
-                </a:lnTo>
-                <a:lnTo>
-                  <a:pt x="1363841" y="94894"/>
-                </a:lnTo>
-                <a:lnTo>
-                  <a:pt x="1330241" y="94894"/>
-                </a:lnTo>
-                <a:lnTo>
-                  <a:pt x="1330241" y="672721"/>
-                </a:lnTo>
-                <a:lnTo>
-                  <a:pt x="3175" y="675896"/>
-                </a:lnTo>
-                <a:close/>
-              </a:path>
-            </a:pathLst>
-          </a:custGeom>
+          <a:prstGeom prst="leftUpArrow">
+            <a:avLst>
+              <a:gd name="adj1" fmla="val 8803"/>
+              <a:gd name="adj2" fmla="val 8803"/>
+              <a:gd name="adj3" fmla="val 11953"/>
+            </a:avLst>
+          </a:prstGeom>
           <a:solidFill>
             <a:schemeClr val="accent2">
               <a:lumMod val="60000"/>
@@ -4112,255 +3563,16 @@
         </p:nvSpPr>
         <p:spPr>
           <a:xfrm>
-            <a:off x="4651947" y="3307478"/>
-            <a:ext cx="1326577" cy="627443"/>
+            <a:off x="4779097" y="3297600"/>
+            <a:ext cx="1166400" cy="662400"/>
           </a:xfrm>
-          <a:custGeom>
-            <a:avLst/>
-            <a:gdLst>
-              <a:gd name="connsiteX0" fmla="*/ 0 w 1274421"/>
-              <a:gd name="connsiteY0" fmla="*/ 613449 h 644596"/>
-              <a:gd name="connsiteX1" fmla="*/ 46269 w 1274421"/>
-              <a:gd name="connsiteY1" fmla="*/ 582302 h 644596"/>
-              <a:gd name="connsiteX2" fmla="*/ 46269 w 1274421"/>
-              <a:gd name="connsiteY2" fmla="*/ 599455 h 644596"/>
-              <a:gd name="connsiteX3" fmla="*/ 1229280 w 1274421"/>
-              <a:gd name="connsiteY3" fmla="*/ 599455 h 644596"/>
-              <a:gd name="connsiteX4" fmla="*/ 1229280 w 1274421"/>
-              <a:gd name="connsiteY4" fmla="*/ 46269 h 644596"/>
-              <a:gd name="connsiteX5" fmla="*/ 1212127 w 1274421"/>
-              <a:gd name="connsiteY5" fmla="*/ 46269 h 644596"/>
-              <a:gd name="connsiteX6" fmla="*/ 1243274 w 1274421"/>
-              <a:gd name="connsiteY6" fmla="*/ 0 h 644596"/>
-              <a:gd name="connsiteX7" fmla="*/ 1274421 w 1274421"/>
-              <a:gd name="connsiteY7" fmla="*/ 46269 h 644596"/>
-              <a:gd name="connsiteX8" fmla="*/ 1257268 w 1274421"/>
-              <a:gd name="connsiteY8" fmla="*/ 46269 h 644596"/>
-              <a:gd name="connsiteX9" fmla="*/ 1257268 w 1274421"/>
-              <a:gd name="connsiteY9" fmla="*/ 627443 h 644596"/>
-              <a:gd name="connsiteX10" fmla="*/ 46269 w 1274421"/>
-              <a:gd name="connsiteY10" fmla="*/ 627443 h 644596"/>
-              <a:gd name="connsiteX11" fmla="*/ 46269 w 1274421"/>
-              <a:gd name="connsiteY11" fmla="*/ 644596 h 644596"/>
-              <a:gd name="connsiteX12" fmla="*/ 0 w 1274421"/>
-              <a:gd name="connsiteY12" fmla="*/ 613449 h 644596"/>
-              <a:gd name="connsiteX0" fmla="*/ 0 w 1228152"/>
-              <a:gd name="connsiteY0" fmla="*/ 644596 h 644596"/>
-              <a:gd name="connsiteX1" fmla="*/ 0 w 1228152"/>
-              <a:gd name="connsiteY1" fmla="*/ 582302 h 644596"/>
-              <a:gd name="connsiteX2" fmla="*/ 0 w 1228152"/>
-              <a:gd name="connsiteY2" fmla="*/ 599455 h 644596"/>
-              <a:gd name="connsiteX3" fmla="*/ 1183011 w 1228152"/>
-              <a:gd name="connsiteY3" fmla="*/ 599455 h 644596"/>
-              <a:gd name="connsiteX4" fmla="*/ 1183011 w 1228152"/>
-              <a:gd name="connsiteY4" fmla="*/ 46269 h 644596"/>
-              <a:gd name="connsiteX5" fmla="*/ 1165858 w 1228152"/>
-              <a:gd name="connsiteY5" fmla="*/ 46269 h 644596"/>
-              <a:gd name="connsiteX6" fmla="*/ 1197005 w 1228152"/>
-              <a:gd name="connsiteY6" fmla="*/ 0 h 644596"/>
-              <a:gd name="connsiteX7" fmla="*/ 1228152 w 1228152"/>
-              <a:gd name="connsiteY7" fmla="*/ 46269 h 644596"/>
-              <a:gd name="connsiteX8" fmla="*/ 1210999 w 1228152"/>
-              <a:gd name="connsiteY8" fmla="*/ 46269 h 644596"/>
-              <a:gd name="connsiteX9" fmla="*/ 1210999 w 1228152"/>
-              <a:gd name="connsiteY9" fmla="*/ 627443 h 644596"/>
-              <a:gd name="connsiteX10" fmla="*/ 0 w 1228152"/>
-              <a:gd name="connsiteY10" fmla="*/ 627443 h 644596"/>
-              <a:gd name="connsiteX11" fmla="*/ 0 w 1228152"/>
-              <a:gd name="connsiteY11" fmla="*/ 644596 h 644596"/>
-              <a:gd name="connsiteX0" fmla="*/ 0 w 1228152"/>
-              <a:gd name="connsiteY0" fmla="*/ 644596 h 644596"/>
-              <a:gd name="connsiteX1" fmla="*/ 0 w 1228152"/>
-              <a:gd name="connsiteY1" fmla="*/ 599455 h 644596"/>
-              <a:gd name="connsiteX2" fmla="*/ 1183011 w 1228152"/>
-              <a:gd name="connsiteY2" fmla="*/ 599455 h 644596"/>
-              <a:gd name="connsiteX3" fmla="*/ 1183011 w 1228152"/>
-              <a:gd name="connsiteY3" fmla="*/ 46269 h 644596"/>
-              <a:gd name="connsiteX4" fmla="*/ 1165858 w 1228152"/>
-              <a:gd name="connsiteY4" fmla="*/ 46269 h 644596"/>
-              <a:gd name="connsiteX5" fmla="*/ 1197005 w 1228152"/>
-              <a:gd name="connsiteY5" fmla="*/ 0 h 644596"/>
-              <a:gd name="connsiteX6" fmla="*/ 1228152 w 1228152"/>
-              <a:gd name="connsiteY6" fmla="*/ 46269 h 644596"/>
-              <a:gd name="connsiteX7" fmla="*/ 1210999 w 1228152"/>
-              <a:gd name="connsiteY7" fmla="*/ 46269 h 644596"/>
-              <a:gd name="connsiteX8" fmla="*/ 1210999 w 1228152"/>
-              <a:gd name="connsiteY8" fmla="*/ 627443 h 644596"/>
-              <a:gd name="connsiteX9" fmla="*/ 0 w 1228152"/>
-              <a:gd name="connsiteY9" fmla="*/ 627443 h 644596"/>
-              <a:gd name="connsiteX10" fmla="*/ 0 w 1228152"/>
-              <a:gd name="connsiteY10" fmla="*/ 644596 h 644596"/>
-              <a:gd name="connsiteX0" fmla="*/ 0 w 1228152"/>
-              <a:gd name="connsiteY0" fmla="*/ 627443 h 627443"/>
-              <a:gd name="connsiteX1" fmla="*/ 0 w 1228152"/>
-              <a:gd name="connsiteY1" fmla="*/ 599455 h 627443"/>
-              <a:gd name="connsiteX2" fmla="*/ 1183011 w 1228152"/>
-              <a:gd name="connsiteY2" fmla="*/ 599455 h 627443"/>
-              <a:gd name="connsiteX3" fmla="*/ 1183011 w 1228152"/>
-              <a:gd name="connsiteY3" fmla="*/ 46269 h 627443"/>
-              <a:gd name="connsiteX4" fmla="*/ 1165858 w 1228152"/>
-              <a:gd name="connsiteY4" fmla="*/ 46269 h 627443"/>
-              <a:gd name="connsiteX5" fmla="*/ 1197005 w 1228152"/>
-              <a:gd name="connsiteY5" fmla="*/ 0 h 627443"/>
-              <a:gd name="connsiteX6" fmla="*/ 1228152 w 1228152"/>
-              <a:gd name="connsiteY6" fmla="*/ 46269 h 627443"/>
-              <a:gd name="connsiteX7" fmla="*/ 1210999 w 1228152"/>
-              <a:gd name="connsiteY7" fmla="*/ 46269 h 627443"/>
-              <a:gd name="connsiteX8" fmla="*/ 1210999 w 1228152"/>
-              <a:gd name="connsiteY8" fmla="*/ 627443 h 627443"/>
-              <a:gd name="connsiteX9" fmla="*/ 0 w 1228152"/>
-              <a:gd name="connsiteY9" fmla="*/ 627443 h 627443"/>
-              <a:gd name="connsiteX0" fmla="*/ 98425 w 1326577"/>
-              <a:gd name="connsiteY0" fmla="*/ 627443 h 627443"/>
-              <a:gd name="connsiteX1" fmla="*/ 0 w 1326577"/>
-              <a:gd name="connsiteY1" fmla="*/ 599455 h 627443"/>
-              <a:gd name="connsiteX2" fmla="*/ 1281436 w 1326577"/>
-              <a:gd name="connsiteY2" fmla="*/ 599455 h 627443"/>
-              <a:gd name="connsiteX3" fmla="*/ 1281436 w 1326577"/>
-              <a:gd name="connsiteY3" fmla="*/ 46269 h 627443"/>
-              <a:gd name="connsiteX4" fmla="*/ 1264283 w 1326577"/>
-              <a:gd name="connsiteY4" fmla="*/ 46269 h 627443"/>
-              <a:gd name="connsiteX5" fmla="*/ 1295430 w 1326577"/>
-              <a:gd name="connsiteY5" fmla="*/ 0 h 627443"/>
-              <a:gd name="connsiteX6" fmla="*/ 1326577 w 1326577"/>
-              <a:gd name="connsiteY6" fmla="*/ 46269 h 627443"/>
-              <a:gd name="connsiteX7" fmla="*/ 1309424 w 1326577"/>
-              <a:gd name="connsiteY7" fmla="*/ 46269 h 627443"/>
-              <a:gd name="connsiteX8" fmla="*/ 1309424 w 1326577"/>
-              <a:gd name="connsiteY8" fmla="*/ 627443 h 627443"/>
-              <a:gd name="connsiteX9" fmla="*/ 98425 w 1326577"/>
-              <a:gd name="connsiteY9" fmla="*/ 627443 h 627443"/>
-              <a:gd name="connsiteX0" fmla="*/ 12700 w 1326577"/>
-              <a:gd name="connsiteY0" fmla="*/ 624268 h 627443"/>
-              <a:gd name="connsiteX1" fmla="*/ 0 w 1326577"/>
-              <a:gd name="connsiteY1" fmla="*/ 599455 h 627443"/>
-              <a:gd name="connsiteX2" fmla="*/ 1281436 w 1326577"/>
-              <a:gd name="connsiteY2" fmla="*/ 599455 h 627443"/>
-              <a:gd name="connsiteX3" fmla="*/ 1281436 w 1326577"/>
-              <a:gd name="connsiteY3" fmla="*/ 46269 h 627443"/>
-              <a:gd name="connsiteX4" fmla="*/ 1264283 w 1326577"/>
-              <a:gd name="connsiteY4" fmla="*/ 46269 h 627443"/>
-              <a:gd name="connsiteX5" fmla="*/ 1295430 w 1326577"/>
-              <a:gd name="connsiteY5" fmla="*/ 0 h 627443"/>
-              <a:gd name="connsiteX6" fmla="*/ 1326577 w 1326577"/>
-              <a:gd name="connsiteY6" fmla="*/ 46269 h 627443"/>
-              <a:gd name="connsiteX7" fmla="*/ 1309424 w 1326577"/>
-              <a:gd name="connsiteY7" fmla="*/ 46269 h 627443"/>
-              <a:gd name="connsiteX8" fmla="*/ 1309424 w 1326577"/>
-              <a:gd name="connsiteY8" fmla="*/ 627443 h 627443"/>
-              <a:gd name="connsiteX9" fmla="*/ 12700 w 1326577"/>
-              <a:gd name="connsiteY9" fmla="*/ 624268 h 627443"/>
-              <a:gd name="connsiteX0" fmla="*/ 0 w 1336102"/>
-              <a:gd name="connsiteY0" fmla="*/ 627443 h 627443"/>
-              <a:gd name="connsiteX1" fmla="*/ 9525 w 1336102"/>
-              <a:gd name="connsiteY1" fmla="*/ 599455 h 627443"/>
-              <a:gd name="connsiteX2" fmla="*/ 1290961 w 1336102"/>
-              <a:gd name="connsiteY2" fmla="*/ 599455 h 627443"/>
-              <a:gd name="connsiteX3" fmla="*/ 1290961 w 1336102"/>
-              <a:gd name="connsiteY3" fmla="*/ 46269 h 627443"/>
-              <a:gd name="connsiteX4" fmla="*/ 1273808 w 1336102"/>
-              <a:gd name="connsiteY4" fmla="*/ 46269 h 627443"/>
-              <a:gd name="connsiteX5" fmla="*/ 1304955 w 1336102"/>
-              <a:gd name="connsiteY5" fmla="*/ 0 h 627443"/>
-              <a:gd name="connsiteX6" fmla="*/ 1336102 w 1336102"/>
-              <a:gd name="connsiteY6" fmla="*/ 46269 h 627443"/>
-              <a:gd name="connsiteX7" fmla="*/ 1318949 w 1336102"/>
-              <a:gd name="connsiteY7" fmla="*/ 46269 h 627443"/>
-              <a:gd name="connsiteX8" fmla="*/ 1318949 w 1336102"/>
-              <a:gd name="connsiteY8" fmla="*/ 627443 h 627443"/>
-              <a:gd name="connsiteX9" fmla="*/ 0 w 1336102"/>
-              <a:gd name="connsiteY9" fmla="*/ 627443 h 627443"/>
-              <a:gd name="connsiteX0" fmla="*/ 0 w 1326577"/>
-              <a:gd name="connsiteY0" fmla="*/ 627443 h 627443"/>
-              <a:gd name="connsiteX1" fmla="*/ 0 w 1326577"/>
-              <a:gd name="connsiteY1" fmla="*/ 599455 h 627443"/>
-              <a:gd name="connsiteX2" fmla="*/ 1281436 w 1326577"/>
-              <a:gd name="connsiteY2" fmla="*/ 599455 h 627443"/>
-              <a:gd name="connsiteX3" fmla="*/ 1281436 w 1326577"/>
-              <a:gd name="connsiteY3" fmla="*/ 46269 h 627443"/>
-              <a:gd name="connsiteX4" fmla="*/ 1264283 w 1326577"/>
-              <a:gd name="connsiteY4" fmla="*/ 46269 h 627443"/>
-              <a:gd name="connsiteX5" fmla="*/ 1295430 w 1326577"/>
-              <a:gd name="connsiteY5" fmla="*/ 0 h 627443"/>
-              <a:gd name="connsiteX6" fmla="*/ 1326577 w 1326577"/>
-              <a:gd name="connsiteY6" fmla="*/ 46269 h 627443"/>
-              <a:gd name="connsiteX7" fmla="*/ 1309424 w 1326577"/>
-              <a:gd name="connsiteY7" fmla="*/ 46269 h 627443"/>
-              <a:gd name="connsiteX8" fmla="*/ 1309424 w 1326577"/>
-              <a:gd name="connsiteY8" fmla="*/ 627443 h 627443"/>
-              <a:gd name="connsiteX9" fmla="*/ 0 w 1326577"/>
-              <a:gd name="connsiteY9" fmla="*/ 627443 h 627443"/>
-            </a:gdLst>
-            <a:ahLst/>
-            <a:cxnLst>
-              <a:cxn ang="0">
-                <a:pos x="connsiteX0" y="connsiteY0"/>
-              </a:cxn>
-              <a:cxn ang="0">
-                <a:pos x="connsiteX1" y="connsiteY1"/>
-              </a:cxn>
-              <a:cxn ang="0">
-                <a:pos x="connsiteX2" y="connsiteY2"/>
-              </a:cxn>
-              <a:cxn ang="0">
-                <a:pos x="connsiteX3" y="connsiteY3"/>
-              </a:cxn>
-              <a:cxn ang="0">
-                <a:pos x="connsiteX4" y="connsiteY4"/>
-              </a:cxn>
-              <a:cxn ang="0">
-                <a:pos x="connsiteX5" y="connsiteY5"/>
-              </a:cxn>
-              <a:cxn ang="0">
-                <a:pos x="connsiteX6" y="connsiteY6"/>
-              </a:cxn>
-              <a:cxn ang="0">
-                <a:pos x="connsiteX7" y="connsiteY7"/>
-              </a:cxn>
-              <a:cxn ang="0">
-                <a:pos x="connsiteX8" y="connsiteY8"/>
-              </a:cxn>
-              <a:cxn ang="0">
-                <a:pos x="connsiteX9" y="connsiteY9"/>
-              </a:cxn>
-            </a:cxnLst>
-            <a:rect l="l" t="t" r="r" b="b"/>
-            <a:pathLst>
-              <a:path w="1326577" h="627443">
-                <a:moveTo>
-                  <a:pt x="0" y="627443"/>
-                </a:moveTo>
-                <a:lnTo>
-                  <a:pt x="0" y="599455"/>
-                </a:lnTo>
-                <a:lnTo>
-                  <a:pt x="1281436" y="599455"/>
-                </a:lnTo>
-                <a:lnTo>
-                  <a:pt x="1281436" y="46269"/>
-                </a:lnTo>
-                <a:lnTo>
-                  <a:pt x="1264283" y="46269"/>
-                </a:lnTo>
-                <a:lnTo>
-                  <a:pt x="1295430" y="0"/>
-                </a:lnTo>
-                <a:lnTo>
-                  <a:pt x="1326577" y="46269"/>
-                </a:lnTo>
-                <a:lnTo>
-                  <a:pt x="1309424" y="46269"/>
-                </a:lnTo>
-                <a:lnTo>
-                  <a:pt x="1309424" y="627443"/>
-                </a:lnTo>
-                <a:lnTo>
-                  <a:pt x="0" y="627443"/>
-                </a:lnTo>
-                <a:close/>
-              </a:path>
-            </a:pathLst>
-          </a:custGeom>
+          <a:prstGeom prst="leftUpArrow">
+            <a:avLst>
+              <a:gd name="adj1" fmla="val 4759"/>
+              <a:gd name="adj2" fmla="val 5830"/>
+              <a:gd name="adj3" fmla="val 7795"/>
+            </a:avLst>
+          </a:prstGeom>
           <a:solidFill>
             <a:schemeClr val="accent4">
               <a:lumMod val="40000"/>
@@ -4654,7 +3866,7 @@
                 <a:latin typeface="Arial" panose="020B0604020202020204" pitchFamily="34" charset="0"/>
                 <a:cs typeface="Arial" panose="020B0604020202020204" pitchFamily="34" charset="0"/>
               </a:rPr>
-              <a:t>Payee (merchant)</a:t>
+              <a:t>Payee (Merchant)</a:t>
             </a:r>
           </a:p>
         </p:txBody>
@@ -5065,13 +4277,13 @@
           <p:nvPr/>
         </p:nvPicPr>
         <p:blipFill>
-          <a:blip r:embed="rId5">
+          <a:blip>
             <a:extLst>
               <a:ext uri="{28A0092B-C50C-407E-A947-70E740481C1C}">
                 <a14:useLocalDpi xmlns:a14="http://schemas.microsoft.com/office/drawing/2010/main" val="0"/>
               </a:ext>
               <a:ext uri="{96DAC541-7B7A-43D3-8B79-37D633B846F1}">
-                <asvg:svgBlip xmlns:asvg="http://schemas.microsoft.com/office/drawing/2016/SVG/main" r:embed="rId6"/>
+                <asvg:svgBlip xmlns:asvg="http://schemas.microsoft.com/office/drawing/2016/SVG/main" r:embed="rId5"/>
               </a:ext>
             </a:extLst>
           </a:blip>
@@ -6588,10 +5800,10 @@
           <p:nvPr/>
         </p:nvPicPr>
         <p:blipFill>
-          <a:blip r:embed="rId7">
+          <a:blip>
             <a:extLst>
               <a:ext uri="{96DAC541-7B7A-43D3-8B79-37D633B846F1}">
-                <asvg:svgBlip xmlns:asvg="http://schemas.microsoft.com/office/drawing/2016/SVG/main" r:embed="rId8"/>
+                <asvg:svgBlip xmlns:asvg="http://schemas.microsoft.com/office/drawing/2016/SVG/main" r:embed="rId6"/>
               </a:ext>
             </a:extLst>
           </a:blip>
@@ -6609,6 +5821,130 @@
           </a:prstGeom>
         </p:spPr>
       </p:pic>
+      <p:sp>
+        <p:nvSpPr>
+          <p:cNvPr id="5" name="Oval 4">
+            <a:extLst>
+              <a:ext uri="{FF2B5EF4-FFF2-40B4-BE49-F238E27FC236}">
+                <a16:creationId xmlns:a16="http://schemas.microsoft.com/office/drawing/2014/main" id="{EE2ECEB1-E096-E42A-B105-099C3E3A149C}"/>
+              </a:ext>
+            </a:extLst>
+          </p:cNvPr>
+          <p:cNvSpPr>
+            <a:spLocks/>
+          </p:cNvSpPr>
+          <p:nvPr/>
+        </p:nvSpPr>
+        <p:spPr>
+          <a:xfrm>
+            <a:off x="4556889" y="2839678"/>
+            <a:ext cx="180000" cy="180000"/>
+          </a:xfrm>
+          <a:prstGeom prst="ellipse">
+            <a:avLst/>
+          </a:prstGeom>
+          <a:solidFill>
+            <a:schemeClr val="bg1"/>
+          </a:solidFill>
+        </p:spPr>
+        <p:style>
+          <a:lnRef idx="2">
+            <a:schemeClr val="accent1">
+              <a:shade val="15000"/>
+            </a:schemeClr>
+          </a:lnRef>
+          <a:fillRef idx="1">
+            <a:schemeClr val="accent1"/>
+          </a:fillRef>
+          <a:effectRef idx="0">
+            <a:schemeClr val="accent1"/>
+          </a:effectRef>
+          <a:fontRef idx="minor">
+            <a:schemeClr val="lt1"/>
+          </a:fontRef>
+        </p:style>
+        <p:txBody>
+          <a:bodyPr wrap="none" lIns="45720" tIns="0" rIns="45720" bIns="0" rtlCol="0" anchor="ctr">
+            <a:noAutofit/>
+          </a:bodyPr>
+          <a:lstStyle/>
+          <a:p>
+            <a:pPr algn="ctr"/>
+            <a:r>
+              <a:rPr lang="en-US" sz="1200" dirty="0">
+                <a:solidFill>
+                  <a:srgbClr val="FF0000"/>
+                </a:solidFill>
+                <a:latin typeface="Consolas" panose="020B0609020204030204" pitchFamily="49" charset="0"/>
+                <a:cs typeface="Consolas" panose="020B0609020204030204" pitchFamily="49" charset="0"/>
+              </a:rPr>
+              <a:t>I</a:t>
+            </a:r>
+          </a:p>
+        </p:txBody>
+      </p:sp>
+      <p:sp>
+        <p:nvSpPr>
+          <p:cNvPr id="15" name="Oval 14">
+            <a:extLst>
+              <a:ext uri="{FF2B5EF4-FFF2-40B4-BE49-F238E27FC236}">
+                <a16:creationId xmlns:a16="http://schemas.microsoft.com/office/drawing/2014/main" id="{02D451E7-BE09-0CB5-4C19-E2518143054E}"/>
+              </a:ext>
+            </a:extLst>
+          </p:cNvPr>
+          <p:cNvSpPr>
+            <a:spLocks/>
+          </p:cNvSpPr>
+          <p:nvPr/>
+        </p:nvSpPr>
+        <p:spPr>
+          <a:xfrm>
+            <a:off x="4560064" y="3830278"/>
+            <a:ext cx="180000" cy="180000"/>
+          </a:xfrm>
+          <a:prstGeom prst="ellipse">
+            <a:avLst/>
+          </a:prstGeom>
+          <a:solidFill>
+            <a:schemeClr val="bg1"/>
+          </a:solidFill>
+        </p:spPr>
+        <p:style>
+          <a:lnRef idx="2">
+            <a:schemeClr val="accent1">
+              <a:shade val="15000"/>
+            </a:schemeClr>
+          </a:lnRef>
+          <a:fillRef idx="1">
+            <a:schemeClr val="accent1"/>
+          </a:fillRef>
+          <a:effectRef idx="0">
+            <a:schemeClr val="accent1"/>
+          </a:effectRef>
+          <a:fontRef idx="minor">
+            <a:schemeClr val="lt1"/>
+          </a:fontRef>
+        </p:style>
+        <p:txBody>
+          <a:bodyPr wrap="none" lIns="45720" tIns="0" rIns="45720" bIns="0" rtlCol="0" anchor="ctr">
+            <a:noAutofit/>
+          </a:bodyPr>
+          <a:lstStyle/>
+          <a:p>
+            <a:pPr algn="ctr"/>
+            <a:r>
+              <a:rPr lang="en-US" sz="1200" dirty="0">
+                <a:solidFill>
+                  <a:srgbClr val="FF0000"/>
+                </a:solidFill>
+                <a:latin typeface="Consolas" panose="020B0609020204030204" pitchFamily="49" charset="0"/>
+                <a:cs typeface="Consolas" panose="020B0609020204030204" pitchFamily="49" charset="0"/>
+              </a:rPr>
+              <a:t>N</a:t>
+            </a:r>
+          </a:p>
+        </p:txBody>
+      </p:sp>
     </p:spTree>
     <p:extLst>
       <p:ext uri="{BB962C8B-B14F-4D97-AF65-F5344CB8AC3E}">

</xml_diff>